<commit_message>
demo: one typeface, Amazon product page, buy-anything close
- Inter for every word in the video and the deck (no monospace).
- Quote scene gets a title: "Another agent asks for gum. Cardano Card
  quotes it."
- Checkout shows the real Amazon listing for the item Cardano Card bought
  (B071GV16XD, $1.32; the viewer's browser location blurred) next to the
  real Agentcard order. The order is placed server-side by Agentcard, so no
  checkout screens are shown.
- Close: "Any agent on Masumi can now buy anything a card can", with
  merchants from Agentcard's live Purchase API catalogue.

Co-Authored-By: Claude Opus 5.5 <noreply@anthropic.com>
</commit_message>
<xml_diff>
--- a/demo/slides/cardano-card.pptx
+++ b/demo/slides/cardano-card.pptx
@@ -1565,9 +1565,9 @@
                 <a:solidFill>
                   <a:srgbClr val="5C5C5C"/>
                 </a:solidFill>
-                <a:latin typeface="JetBrains Mono" pitchFamily="34" charset="0"/>
-                <a:ea typeface="JetBrains Mono" pitchFamily="34" charset="-122"/>
-                <a:cs typeface="JetBrains Mono" pitchFamily="34" charset="-120"/>
+                <a:latin typeface="Inter" pitchFamily="34" charset="0"/>
+                <a:ea typeface="Inter" pitchFamily="34" charset="-122"/>
+                <a:cs typeface="Inter" pitchFamily="34" charset="-120"/>
               </a:rPr>
               <a:t>built on</a:t>
             </a:r>
@@ -1691,9 +1691,9 @@
                 <a:solidFill>
                   <a:srgbClr val="5C5C5C"/>
                 </a:solidFill>
-                <a:latin typeface="JetBrains Mono" pitchFamily="34" charset="0"/>
-                <a:ea typeface="JetBrains Mono" pitchFamily="34" charset="-122"/>
-                <a:cs typeface="JetBrains Mono" pitchFamily="34" charset="-120"/>
+                <a:latin typeface="Inter" pitchFamily="34" charset="0"/>
+                <a:ea typeface="Inter" pitchFamily="34" charset="-122"/>
+                <a:cs typeface="Inter" pitchFamily="34" charset="-120"/>
               </a:rPr>
               <a:t>TOKEN2049 Origins · Mason &amp; Ezra</a:t>
             </a:r>
@@ -3002,9 +3002,9 @@
                 <a:solidFill>
                   <a:srgbClr val="5C5C5C"/>
                 </a:solidFill>
-                <a:latin typeface="JetBrains Mono" pitchFamily="34" charset="0"/>
-                <a:ea typeface="JetBrains Mono" pitchFamily="34" charset="-122"/>
-                <a:cs typeface="JetBrains Mono" pitchFamily="34" charset="-120"/>
+                <a:latin typeface="Inter" pitchFamily="34" charset="0"/>
+                <a:ea typeface="Inter" pitchFamily="34" charset="-122"/>
+                <a:cs typeface="Inter" pitchFamily="34" charset="-120"/>
               </a:rPr>
               <a:t>If no purchase happens, the buyer is refunded from escrow. Nothing is ever bought twice.</a:t>
             </a:r>
@@ -3153,9 +3153,9 @@
                 <a:solidFill>
                   <a:srgbClr val="0A0A0A"/>
                 </a:solidFill>
-                <a:latin typeface="JetBrains Mono" pitchFamily="34" charset="0"/>
-                <a:ea typeface="JetBrains Mono" pitchFamily="34" charset="-122"/>
-                <a:cs typeface="JetBrains Mono" pitchFamily="34" charset="-120"/>
+                <a:latin typeface="Inter" pitchFamily="34" charset="0"/>
+                <a:ea typeface="Inter" pitchFamily="34" charset="-122"/>
+                <a:cs typeface="Inter" pitchFamily="34" charset="-120"/>
               </a:rPr>
               <a:t>20:37:59 SGT</a:t>
             </a:r>
@@ -3231,9 +3231,9 @@
                 <a:solidFill>
                   <a:srgbClr val="5C5C5C"/>
                 </a:solidFill>
-                <a:latin typeface="JetBrains Mono" pitchFamily="34" charset="0"/>
-                <a:ea typeface="JetBrains Mono" pitchFamily="34" charset="-122"/>
-                <a:cs typeface="JetBrains Mono" pitchFamily="34" charset="-120"/>
+                <a:latin typeface="Inter" pitchFamily="34" charset="0"/>
+                <a:ea typeface="Inter" pitchFamily="34" charset="-122"/>
+                <a:cs typeface="Inter" pitchFamily="34" charset="-120"/>
               </a:rPr>
               <a:t>block 5,260,604</a:t>
             </a:r>
@@ -3295,9 +3295,9 @@
                 <a:solidFill>
                   <a:srgbClr val="0A0A0A"/>
                 </a:solidFill>
-                <a:latin typeface="JetBrains Mono" pitchFamily="34" charset="0"/>
-                <a:ea typeface="JetBrains Mono" pitchFamily="34" charset="-122"/>
-                <a:cs typeface="JetBrains Mono" pitchFamily="34" charset="-120"/>
+                <a:latin typeface="Inter" pitchFamily="34" charset="0"/>
+                <a:ea typeface="Inter" pitchFamily="34" charset="-122"/>
+                <a:cs typeface="Inter" pitchFamily="34" charset="-120"/>
               </a:rPr>
               <a:t>20:39:18 SGT</a:t>
             </a:r>
@@ -3373,9 +3373,9 @@
                 <a:solidFill>
                   <a:srgbClr val="5C5C5C"/>
                 </a:solidFill>
-                <a:latin typeface="JetBrains Mono" pitchFamily="34" charset="0"/>
-                <a:ea typeface="JetBrains Mono" pitchFamily="34" charset="-122"/>
-                <a:cs typeface="JetBrains Mono" pitchFamily="34" charset="-120"/>
+                <a:latin typeface="Inter" pitchFamily="34" charset="0"/>
+                <a:ea typeface="Inter" pitchFamily="34" charset="-122"/>
+                <a:cs typeface="Inter" pitchFamily="34" charset="-120"/>
               </a:rPr>
               <a:t>Trident gum, 14 pc · $1.32</a:t>
             </a:r>
@@ -3437,9 +3437,9 @@
                 <a:solidFill>
                   <a:srgbClr val="0A0A0A"/>
                 </a:solidFill>
-                <a:latin typeface="JetBrains Mono" pitchFamily="34" charset="0"/>
-                <a:ea typeface="JetBrains Mono" pitchFamily="34" charset="-122"/>
-                <a:cs typeface="JetBrains Mono" pitchFamily="34" charset="-120"/>
+                <a:latin typeface="Inter" pitchFamily="34" charset="0"/>
+                <a:ea typeface="Inter" pitchFamily="34" charset="-122"/>
+                <a:cs typeface="Inter" pitchFamily="34" charset="-120"/>
               </a:rPr>
               <a:t>20:39:36 SGT</a:t>
             </a:r>
@@ -3515,9 +3515,9 @@
                 <a:solidFill>
                   <a:srgbClr val="5C5C5C"/>
                 </a:solidFill>
-                <a:latin typeface="JetBrains Mono" pitchFamily="34" charset="0"/>
-                <a:ea typeface="JetBrains Mono" pitchFamily="34" charset="-122"/>
-                <a:cs typeface="JetBrains Mono" pitchFamily="34" charset="-120"/>
+                <a:latin typeface="Inter" pitchFamily="34" charset="0"/>
+                <a:ea typeface="Inter" pitchFamily="34" charset="-122"/>
+                <a:cs typeface="Inter" pitchFamily="34" charset="-120"/>
               </a:rPr>
               <a:t>block 5,260,609</a:t>
             </a:r>
@@ -3632,9 +3632,9 @@
                 <a:solidFill>
                   <a:srgbClr val="5C5C5C"/>
                 </a:solidFill>
-                <a:latin typeface="JetBrains Mono" pitchFamily="34" charset="0"/>
-                <a:ea typeface="JetBrains Mono" pitchFamily="34" charset="-122"/>
-                <a:cs typeface="JetBrains Mono" pitchFamily="34" charset="-120"/>
+                <a:latin typeface="Inter" pitchFamily="34" charset="0"/>
+                <a:ea typeface="Inter" pitchFamily="34" charset="-122"/>
+                <a:cs typeface="Inter" pitchFamily="34" charset="-120"/>
               </a:rPr>
               <a:t>Cardano Preprod · Agentcard order 9a193914… · tx 7fd13a227f… and b30b139b04…</a:t>
             </a:r>
@@ -4319,9 +4319,9 @@
                 <a:solidFill>
                   <a:srgbClr val="5C5C5C"/>
                 </a:solidFill>
-                <a:latin typeface="JetBrains Mono" pitchFamily="34" charset="0"/>
-                <a:ea typeface="JetBrains Mono" pitchFamily="34" charset="-122"/>
-                <a:cs typeface="JetBrains Mono" pitchFamily="34" charset="-120"/>
+                <a:latin typeface="Inter" pitchFamily="34" charset="0"/>
+                <a:ea typeface="Inter" pitchFamily="34" charset="-122"/>
+                <a:cs typeface="Inter" pitchFamily="34" charset="-120"/>
               </a:rPr>
               <a:t>Buyers</a:t>
             </a:r>
@@ -4568,9 +4568,9 @@
                 <a:solidFill>
                   <a:srgbClr val="5C5C5C"/>
                 </a:solidFill>
-                <a:latin typeface="JetBrains Mono" pitchFamily="34" charset="0"/>
-                <a:ea typeface="JetBrains Mono" pitchFamily="34" charset="-122"/>
-                <a:cs typeface="JetBrains Mono" pitchFamily="34" charset="-120"/>
+                <a:latin typeface="Inter" pitchFamily="34" charset="0"/>
+                <a:ea typeface="Inter" pitchFamily="34" charset="-122"/>
+                <a:cs typeface="Inter" pitchFamily="34" charset="-120"/>
               </a:rPr>
               <a:t>Cardano Card</a:t>
             </a:r>
@@ -4817,9 +4817,9 @@
                 <a:solidFill>
                   <a:srgbClr val="5C5C5C"/>
                 </a:solidFill>
-                <a:latin typeface="JetBrains Mono" pitchFamily="34" charset="0"/>
-                <a:ea typeface="JetBrains Mono" pitchFamily="34" charset="-122"/>
-                <a:cs typeface="JetBrains Mono" pitchFamily="34" charset="-120"/>
+                <a:latin typeface="Inter" pitchFamily="34" charset="0"/>
+                <a:ea typeface="Inter" pitchFamily="34" charset="-122"/>
+                <a:cs typeface="Inter" pitchFamily="34" charset="-120"/>
               </a:rPr>
               <a:t>Rails</a:t>
             </a:r>

</xml_diff>